<commit_message>
Fix Singapore analysis: >$5B LE threshold + Ops/SAP audit trail
- LE qualification now uses single >$5B turnover threshold
- Source column renamed: "Ops" (Aashita/NTT), "SAP" (MOVE list), "Both"
- Summary sheet includes scoring methodology and audit trail
- All slides updated with clear Ops vs SAP source attribution
- Added LE Qualified column to Master LE List and Priority Matrix

https://claude.ai/code/session_018CdomwcM2t3v3UWZ6osXnY
</commit_message>
<xml_diff>
--- a/backend/analysis/SG_GTM_Presentation.pptx
+++ b/backend/analysis/SG_GTM_Presentation.pptx
@@ -3217,7 +3217,7 @@
         </p:nvSpPr>
         <p:spPr>
           <a:xfrm>
-            <a:off x="731520" y="5029200"/>
+            <a:off x="731520" y="4754880"/>
             <a:ext cx="10698480" cy="457200"/>
           </a:xfrm>
           <a:prstGeom prst="rect">
@@ -3232,14 +3232,14 @@
           <a:lstStyle/>
           <a:p>
             <a:pPr algn="l">
-              <a:defRPr sz="1200" b="0">
-                <a:solidFill>
-                  <a:srgbClr val="8FAADC"/>
+              <a:defRPr sz="1400" b="1">
+                <a:solidFill>
+                  <a:srgbClr val="BF8F00"/>
                 </a:solidFill>
               </a:defRPr>
             </a:pPr>
             <a:r>
-              <a:t>Sources: Aashita/Ops (SG Target List) | SAP SEA MOVE List | NTT Data AMS</a:t>
+              <a:t>LE Definition: Company Turnover &gt; $5B USD</a:t>
             </a:r>
           </a:p>
         </p:txBody>
@@ -3252,8 +3252,51 @@
         </p:nvSpPr>
         <p:spPr>
           <a:xfrm>
-            <a:off x="731520" y="5669280"/>
-            <a:ext cx="10698480" cy="457200"/>
+            <a:off x="731520" y="5303520"/>
+            <a:ext cx="10698480" cy="731520"/>
+          </a:xfrm>
+          <a:prstGeom prst="rect">
+            <a:avLst/>
+          </a:prstGeom>
+          <a:noFill/>
+        </p:spPr>
+        <p:txBody>
+          <a:bodyPr wrap="square">
+            <a:spAutoFit/>
+          </a:bodyPr>
+          <a:lstStyle/>
+          <a:p>
+            <a:pPr algn="l">
+              <a:defRPr sz="1200" b="0">
+                <a:solidFill>
+                  <a:srgbClr val="8FAADC"/>
+                </a:solidFill>
+              </a:defRPr>
+            </a:pPr>
+            <a:r>
+              <a:t>Data Sources:</a:t>
+            </a:r>
+            <a:br/>
+            <a:r>
+              <a:t>  Ops = Aashita/NTT Operations Target List (SG Sheet)</a:t>
+            </a:r>
+            <a:br/>
+            <a:r>
+              <a:t>  SAP = SAP SEA MOVE List -LE</a:t>
+            </a:r>
+          </a:p>
+        </p:txBody>
+      </p:sp>
+      <p:sp>
+        <p:nvSpPr>
+          <p:cNvPr id="7" name="TextBox 6"/>
+          <p:cNvSpPr txBox="1"/>
+          <p:nvPr/>
+        </p:nvSpPr>
+        <p:spPr>
+          <a:xfrm>
+            <a:off x="731520" y="6126480"/>
+            <a:ext cx="10698480" cy="365760"/>
           </a:xfrm>
           <a:prstGeom prst="rect">
             <a:avLst/>
@@ -3391,7 +3434,7 @@
               </a:defRPr>
             </a:pPr>
             <a:r>
-              <a:t>NTT Target</a:t>
+              <a:t>Ops Target</a:t>
             </a:r>
             <a:br/>
             <a:r>
@@ -3735,7 +3778,7 @@
             </a:r>
             <a:br/>
             <a:r>
-              <a:t>(Both Sources)</a:t>
+              <a:t>(Ops + SAP)</a:t>
             </a:r>
           </a:p>
         </p:txBody>
@@ -3773,7 +3816,7 @@
               </a:defRPr>
             </a:pPr>
             <a:r>
-              <a:t>• BFSI dominates: 42 accounts (36% of NTT target list)</a:t>
+              <a:t>• All 115 Ops accounts qualify as LE (turnover &gt; $5B)</a:t>
             </a:r>
           </a:p>
           <a:p>
@@ -3788,7 +3831,7 @@
               </a:defRPr>
             </a:pPr>
             <a:r>
-              <a:t>• Energy &amp; Utilities: 25 accounts — strong SAP migration pipeline</a:t>
+              <a:t>• BFSI dominates: 42 accounts (36% of Ops target list)</a:t>
             </a:r>
           </a:p>
           <a:p>
@@ -3803,7 +3846,7 @@
               </a:defRPr>
             </a:pPr>
             <a:r>
-              <a:t>• Wholesale Distribution: 13 accounts with high revenue concentration</a:t>
+              <a:t>• Energy &amp; Utilities: 25 accounts — strong SAP migration pipeline</a:t>
             </a:r>
           </a:p>
           <a:p>
@@ -3848,7 +3891,7 @@
               </a:defRPr>
             </a:pPr>
             <a:r>
-              <a:t>• Revenue range: $5B to $433B USD turnover</a:t>
+              <a:t>• Source: Ops = Aashita/NTT team | SAP = SAP MOVE List</a:t>
             </a:r>
           </a:p>
         </p:txBody>
@@ -3921,7 +3964,7 @@
               </a:defRPr>
             </a:pPr>
             <a:r>
-              <a:t>• Only 6 accounts overlap between NTT list &amp; SAP MOVE list</a:t>
+              <a:t>• Only 6 accounts overlap between Ops &amp; SAP lists</a:t>
             </a:r>
           </a:p>
           <a:p>
@@ -3936,7 +3979,7 @@
               </a:defRPr>
             </a:pPr>
             <a:r>
-              <a:t>• 109 NTT targets NOT on SAP MOVE — missing SAP alignment?</a:t>
+              <a:t>• 109 Ops targets NOT on SAP MOVE — missing SAP alignment?</a:t>
             </a:r>
           </a:p>
           <a:p>
@@ -3951,7 +3994,7 @@
               </a:defRPr>
             </a:pPr>
             <a:r>
-              <a:t>• 69 SAP MOVE accounts NOT on NTT list — untapped potential</a:t>
+              <a:t>• 69 SAP MOVE accounts NOT on Ops list — untapped potential</a:t>
             </a:r>
           </a:p>
           <a:p>
@@ -5399,7 +5442,7 @@
               </a:defRPr>
             </a:pPr>
             <a:r>
-              <a:t>Source: SG Sheet (Aashita/Ops) | 115 total accounts across 18 industries</a:t>
+              <a:t>Source: Ops (SG Sheet) | All 115 accounts LE qualified (&gt;$5B turnover)</a:t>
             </a:r>
           </a:p>
         </p:txBody>
@@ -5680,26 +5723,26 @@
                         </a:defRPr>
                       </a:pPr>
                       <a:r>
-                        <a:t>Ministry of Manpower</a:t>
-                      </a:r>
-                    </a:p>
-                  </a:txBody>
-                  <a:tcPr/>
-                </a:tc>
-                <a:tc>
-                  <a:txBody>
-                    <a:bodyPr/>
-                    <a:lstStyle/>
-                    <a:p>
-                      <a:pPr>
-                        <a:defRPr sz="1000">
-                          <a:solidFill>
-                            <a:srgbClr val="333333"/>
-                          </a:solidFill>
-                        </a:defRPr>
-                      </a:pPr>
-                      <a:r>
-                        <a:t>Wholesale Distribution</a:t>
+                        <a:t>ASE Singapore Pte Ltd</a:t>
+                      </a:r>
+                    </a:p>
+                  </a:txBody>
+                  <a:tcPr/>
+                </a:tc>
+                <a:tc>
+                  <a:txBody>
+                    <a:bodyPr/>
+                    <a:lstStyle/>
+                    <a:p>
+                      <a:pPr>
+                        <a:defRPr sz="1000">
+                          <a:solidFill>
+                            <a:srgbClr val="333333"/>
+                          </a:solidFill>
+                        </a:defRPr>
+                      </a:pPr>
+                      <a:r>
+                        <a:t>Electronics</a:t>
                       </a:r>
                     </a:p>
                   </a:txBody>
@@ -5756,26 +5799,26 @@
                         </a:defRPr>
                       </a:pPr>
                       <a:r>
-                        <a:t>$433.5B</a:t>
-                      </a:r>
-                    </a:p>
-                  </a:txBody>
-                  <a:tcPr/>
-                </a:tc>
-                <a:tc>
-                  <a:txBody>
-                    <a:bodyPr/>
-                    <a:lstStyle/>
-                    <a:p>
-                      <a:pPr>
-                        <a:defRPr sz="1000">
-                          <a:solidFill>
-                            <a:srgbClr val="333333"/>
-                          </a:solidFill>
-                        </a:defRPr>
-                      </a:pPr>
-                      <a:r>
-                        <a:t>8</a:t>
+                        <a:t>$18.4B</a:t>
+                      </a:r>
+                    </a:p>
+                  </a:txBody>
+                  <a:tcPr/>
+                </a:tc>
+                <a:tc>
+                  <a:txBody>
+                    <a:bodyPr/>
+                    <a:lstStyle/>
+                    <a:p>
+                      <a:pPr>
+                        <a:defRPr sz="1000">
+                          <a:solidFill>
+                            <a:srgbClr val="333333"/>
+                          </a:solidFill>
+                        </a:defRPr>
+                      </a:pPr>
+                      <a:r>
+                        <a:t>7</a:t>
                       </a:r>
                     </a:p>
                   </a:txBody>
@@ -5815,26 +5858,26 @@
                         </a:defRPr>
                       </a:pPr>
                       <a:r>
-                        <a:t>RGE Pte. Ltd.</a:t>
-                      </a:r>
-                    </a:p>
-                  </a:txBody>
-                  <a:tcPr/>
-                </a:tc>
-                <a:tc>
-                  <a:txBody>
-                    <a:bodyPr/>
-                    <a:lstStyle/>
-                    <a:p>
-                      <a:pPr>
-                        <a:defRPr sz="1000">
-                          <a:solidFill>
-                            <a:srgbClr val="333333"/>
-                          </a:solidFill>
-                        </a:defRPr>
-                      </a:pPr>
-                      <a:r>
-                        <a:t>Energy &amp; Utility</a:t>
+                        <a:t>DAIKIN ASIA SERVICING PTE LTD</a:t>
+                      </a:r>
+                    </a:p>
+                  </a:txBody>
+                  <a:tcPr/>
+                </a:tc>
+                <a:tc>
+                  <a:txBody>
+                    <a:bodyPr/>
+                    <a:lstStyle/>
+                    <a:p>
+                      <a:pPr>
+                        <a:defRPr sz="1000">
+                          <a:solidFill>
+                            <a:srgbClr val="333333"/>
+                          </a:solidFill>
+                        </a:defRPr>
+                      </a:pPr>
+                      <a:r>
+                        <a:t>Electronics</a:t>
                       </a:r>
                     </a:p>
                   </a:txBody>
@@ -5891,7 +5934,7 @@
                         </a:defRPr>
                       </a:pPr>
                       <a:r>
-                        <a:t>$40.0B</a:t>
+                        <a:t>$31.3B</a:t>
                       </a:r>
                     </a:p>
                   </a:txBody>
@@ -5950,26 +5993,26 @@
                         </a:defRPr>
                       </a:pPr>
                       <a:r>
-                        <a:t>DAIKIN ASIA SERVICING PTE LTD</a:t>
-                      </a:r>
-                    </a:p>
-                  </a:txBody>
-                  <a:tcPr/>
-                </a:tc>
-                <a:tc>
-                  <a:txBody>
-                    <a:bodyPr/>
-                    <a:lstStyle/>
-                    <a:p>
-                      <a:pPr>
-                        <a:defRPr sz="1000">
-                          <a:solidFill>
-                            <a:srgbClr val="333333"/>
-                          </a:solidFill>
-                        </a:defRPr>
-                      </a:pPr>
-                      <a:r>
-                        <a:t>Electronics</a:t>
+                        <a:t>RGE Pte. Ltd.</a:t>
+                      </a:r>
+                    </a:p>
+                  </a:txBody>
+                  <a:tcPr/>
+                </a:tc>
+                <a:tc>
+                  <a:txBody>
+                    <a:bodyPr/>
+                    <a:lstStyle/>
+                    <a:p>
+                      <a:pPr>
+                        <a:defRPr sz="1000">
+                          <a:solidFill>
+                            <a:srgbClr val="333333"/>
+                          </a:solidFill>
+                        </a:defRPr>
+                      </a:pPr>
+                      <a:r>
+                        <a:t>Energy &amp; Utility</a:t>
                       </a:r>
                     </a:p>
                   </a:txBody>
@@ -6026,7 +6069,7 @@
                         </a:defRPr>
                       </a:pPr>
                       <a:r>
-                        <a:t>$31.3B</a:t>
+                        <a:t>$40.0B</a:t>
                       </a:r>
                     </a:p>
                   </a:txBody>
@@ -6085,26 +6128,26 @@
                         </a:defRPr>
                       </a:pPr>
                       <a:r>
-                        <a:t>TOYOTA MOTOR ASIA (SINGAPORE) PTE. LTD.</a:t>
-                      </a:r>
-                    </a:p>
-                  </a:txBody>
-                  <a:tcPr/>
-                </a:tc>
-                <a:tc>
-                  <a:txBody>
-                    <a:bodyPr/>
-                    <a:lstStyle/>
-                    <a:p>
-                      <a:pPr>
-                        <a:defRPr sz="1000">
-                          <a:solidFill>
-                            <a:srgbClr val="333333"/>
-                          </a:solidFill>
-                        </a:defRPr>
-                      </a:pPr>
-                      <a:r>
-                        <a:t>Automotive</a:t>
+                        <a:t>The Monetary Authority of Singapore</a:t>
+                      </a:r>
+                    </a:p>
+                  </a:txBody>
+                  <a:tcPr/>
+                </a:tc>
+                <a:tc>
+                  <a:txBody>
+                    <a:bodyPr/>
+                    <a:lstStyle/>
+                    <a:p>
+                      <a:pPr>
+                        <a:defRPr sz="1000">
+                          <a:solidFill>
+                            <a:srgbClr val="333333"/>
+                          </a:solidFill>
+                        </a:defRPr>
+                      </a:pPr>
+                      <a:r>
+                        <a:t>BFSI</a:t>
                       </a:r>
                     </a:p>
                   </a:txBody>
@@ -6161,7 +6204,7 @@
                         </a:defRPr>
                       </a:pPr>
                       <a:r>
-                        <a:t>$23.2B</a:t>
+                        <a:t>$10.7B</a:t>
                       </a:r>
                     </a:p>
                   </a:txBody>
@@ -6220,26 +6263,26 @@
                         </a:defRPr>
                       </a:pPr>
                       <a:r>
-                        <a:t>MICRON SEMICONDUCTOR ASIA OPERATIONS PTE. LTD</a:t>
-                      </a:r>
-                    </a:p>
-                  </a:txBody>
-                  <a:tcPr/>
-                </a:tc>
-                <a:tc>
-                  <a:txBody>
-                    <a:bodyPr/>
-                    <a:lstStyle/>
-                    <a:p>
-                      <a:pPr>
-                        <a:defRPr sz="1000">
-                          <a:solidFill>
-                            <a:srgbClr val="333333"/>
-                          </a:solidFill>
-                        </a:defRPr>
-                      </a:pPr>
-                      <a:r>
-                        <a:t>High Tech</a:t>
+                        <a:t>Ministry of Manpower</a:t>
+                      </a:r>
+                    </a:p>
+                  </a:txBody>
+                  <a:tcPr/>
+                </a:tc>
+                <a:tc>
+                  <a:txBody>
+                    <a:bodyPr/>
+                    <a:lstStyle/>
+                    <a:p>
+                      <a:pPr>
+                        <a:defRPr sz="1000">
+                          <a:solidFill>
+                            <a:srgbClr val="333333"/>
+                          </a:solidFill>
+                        </a:defRPr>
+                      </a:pPr>
+                      <a:r>
+                        <a:t>Wholesale Distribution</a:t>
                       </a:r>
                     </a:p>
                   </a:txBody>
@@ -6296,7 +6339,7 @@
                         </a:defRPr>
                       </a:pPr>
                       <a:r>
-                        <a:t>$25.4B</a:t>
+                        <a:t>$433.5B</a:t>
                       </a:r>
                     </a:p>
                   </a:txBody>
@@ -6355,26 +6398,26 @@
                         </a:defRPr>
                       </a:pPr>
                       <a:r>
-                        <a:t>KENNAMETAL DISTRIBUTION SERVICES ASIA PTE. LT</a:t>
-                      </a:r>
-                    </a:p>
-                  </a:txBody>
-                  <a:tcPr/>
-                </a:tc>
-                <a:tc>
-                  <a:txBody>
-                    <a:bodyPr/>
-                    <a:lstStyle/>
-                    <a:p>
-                      <a:pPr>
-                        <a:defRPr sz="1000">
-                          <a:solidFill>
-                            <a:srgbClr val="333333"/>
-                          </a:solidFill>
-                        </a:defRPr>
-                      </a:pPr>
-                      <a:r>
-                        <a:t>Wholesale Distribution</a:t>
+                        <a:t>SINGAPORE POOLS (PRIVATE) LIMITED</a:t>
+                      </a:r>
+                    </a:p>
+                  </a:txBody>
+                  <a:tcPr/>
+                </a:tc>
+                <a:tc>
+                  <a:txBody>
+                    <a:bodyPr/>
+                    <a:lstStyle/>
+                    <a:p>
+                      <a:pPr>
+                        <a:defRPr sz="1000">
+                          <a:solidFill>
+                            <a:srgbClr val="333333"/>
+                          </a:solidFill>
+                        </a:defRPr>
+                      </a:pPr>
+                      <a:r>
+                        <a:t>Hospitality</a:t>
                       </a:r>
                     </a:p>
                   </a:txBody>
@@ -6431,7 +6474,7 @@
                         </a:defRPr>
                       </a:pPr>
                       <a:r>
-                        <a:t>$43.0B</a:t>
+                        <a:t>$12.2B</a:t>
                       </a:r>
                     </a:p>
                   </a:txBody>
@@ -6490,26 +6533,26 @@
                         </a:defRPr>
                       </a:pPr>
                       <a:r>
-                        <a:t>APPLIED MATERIALS SOUTH EAST ASIA PTE. LTD.</a:t>
-                      </a:r>
-                    </a:p>
-                  </a:txBody>
-                  <a:tcPr/>
-                </a:tc>
-                <a:tc>
-                  <a:txBody>
-                    <a:bodyPr/>
-                    <a:lstStyle/>
-                    <a:p>
-                      <a:pPr>
-                        <a:defRPr sz="1000">
-                          <a:solidFill>
-                            <a:srgbClr val="333333"/>
-                          </a:solidFill>
-                        </a:defRPr>
-                      </a:pPr>
-                      <a:r>
-                        <a:t>Wholesale Distribution</a:t>
+                        <a:t>United Overseas Bank Limited</a:t>
+                      </a:r>
+                    </a:p>
+                  </a:txBody>
+                  <a:tcPr/>
+                </a:tc>
+                <a:tc>
+                  <a:txBody>
+                    <a:bodyPr/>
+                    <a:lstStyle/>
+                    <a:p>
+                      <a:pPr>
+                        <a:defRPr sz="1000">
+                          <a:solidFill>
+                            <a:srgbClr val="333333"/>
+                          </a:solidFill>
+                        </a:defRPr>
+                      </a:pPr>
+                      <a:r>
+                        <a:t>BFSI</a:t>
                       </a:r>
                     </a:p>
                   </a:txBody>
@@ -6566,7 +6609,7 @@
                         </a:defRPr>
                       </a:pPr>
                       <a:r>
-                        <a:t>$21.7B</a:t>
+                        <a:t>$17.6B</a:t>
                       </a:r>
                     </a:p>
                   </a:txBody>
@@ -6625,26 +6668,26 @@
                         </a:defRPr>
                       </a:pPr>
                       <a:r>
-                        <a:t>GLENCORE SINGAPORE PTE. LTD.</a:t>
-                      </a:r>
-                    </a:p>
-                  </a:txBody>
-                  <a:tcPr/>
-                </a:tc>
-                <a:tc>
-                  <a:txBody>
-                    <a:bodyPr/>
-                    <a:lstStyle/>
-                    <a:p>
-                      <a:pPr>
-                        <a:defRPr sz="1000">
-                          <a:solidFill>
-                            <a:srgbClr val="333333"/>
-                          </a:solidFill>
-                        </a:defRPr>
-                      </a:pPr>
-                      <a:r>
-                        <a:t>Energy &amp; Utility</a:t>
+                        <a:t>TOYOTA MOTOR ASIA (SINGAPORE) PTE. LTD.</a:t>
+                      </a:r>
+                    </a:p>
+                  </a:txBody>
+                  <a:tcPr/>
+                </a:tc>
+                <a:tc>
+                  <a:txBody>
+                    <a:bodyPr/>
+                    <a:lstStyle/>
+                    <a:p>
+                      <a:pPr>
+                        <a:defRPr sz="1000">
+                          <a:solidFill>
+                            <a:srgbClr val="333333"/>
+                          </a:solidFill>
+                        </a:defRPr>
+                      </a:pPr>
+                      <a:r>
+                        <a:t>Automotive</a:t>
                       </a:r>
                     </a:p>
                   </a:txBody>
@@ -6701,7 +6744,7 @@
                         </a:defRPr>
                       </a:pPr>
                       <a:r>
-                        <a:t>$39.1B</a:t>
+                        <a:t>$23.2B</a:t>
                       </a:r>
                     </a:p>
                   </a:txBody>
@@ -6760,26 +6803,26 @@
                         </a:defRPr>
                       </a:pPr>
                       <a:r>
-                        <a:t>SINGAPORE POOLS (PRIVATE) LIMITED</a:t>
-                      </a:r>
-                    </a:p>
-                  </a:txBody>
-                  <a:tcPr/>
-                </a:tc>
-                <a:tc>
-                  <a:txBody>
-                    <a:bodyPr/>
-                    <a:lstStyle/>
-                    <a:p>
-                      <a:pPr>
-                        <a:defRPr sz="1000">
-                          <a:solidFill>
-                            <a:srgbClr val="333333"/>
-                          </a:solidFill>
-                        </a:defRPr>
-                      </a:pPr>
-                      <a:r>
-                        <a:t>Hospitality</a:t>
+                        <a:t>MICRON SEMICONDUCTOR ASIA OPERATIONS PTE. LTD</a:t>
+                      </a:r>
+                    </a:p>
+                  </a:txBody>
+                  <a:tcPr/>
+                </a:tc>
+                <a:tc>
+                  <a:txBody>
+                    <a:bodyPr/>
+                    <a:lstStyle/>
+                    <a:p>
+                      <a:pPr>
+                        <a:defRPr sz="1000">
+                          <a:solidFill>
+                            <a:srgbClr val="333333"/>
+                          </a:solidFill>
+                        </a:defRPr>
+                      </a:pPr>
+                      <a:r>
+                        <a:t>High Tech</a:t>
                       </a:r>
                     </a:p>
                   </a:txBody>
@@ -6836,26 +6879,26 @@
                         </a:defRPr>
                       </a:pPr>
                       <a:r>
-                        <a:t>$12.2B</a:t>
-                      </a:r>
-                    </a:p>
-                  </a:txBody>
-                  <a:tcPr/>
-                </a:tc>
-                <a:tc>
-                  <a:txBody>
-                    <a:bodyPr/>
-                    <a:lstStyle/>
-                    <a:p>
-                      <a:pPr>
-                        <a:defRPr sz="1000">
-                          <a:solidFill>
-                            <a:srgbClr val="333333"/>
-                          </a:solidFill>
-                        </a:defRPr>
-                      </a:pPr>
-                      <a:r>
-                        <a:t>6</a:t>
+                        <a:t>$25.4B</a:t>
+                      </a:r>
+                    </a:p>
+                  </a:txBody>
+                  <a:tcPr/>
+                </a:tc>
+                <a:tc>
+                  <a:txBody>
+                    <a:bodyPr/>
+                    <a:lstStyle/>
+                    <a:p>
+                      <a:pPr>
+                        <a:defRPr sz="1000">
+                          <a:solidFill>
+                            <a:srgbClr val="333333"/>
+                          </a:solidFill>
+                        </a:defRPr>
+                      </a:pPr>
+                      <a:r>
+                        <a:t>7</a:t>
                       </a:r>
                     </a:p>
                   </a:txBody>
@@ -6895,45 +6938,45 @@
                         </a:defRPr>
                       </a:pPr>
                       <a:r>
-                        <a:t>ADITYA BIRLA GLOBAL TRADING (SINGAPORE)</a:t>
-                      </a:r>
-                    </a:p>
-                  </a:txBody>
-                  <a:tcPr/>
-                </a:tc>
-                <a:tc>
-                  <a:txBody>
-                    <a:bodyPr/>
-                    <a:lstStyle/>
-                    <a:p>
-                      <a:pPr>
-                        <a:defRPr sz="1000">
-                          <a:solidFill>
-                            <a:srgbClr val="333333"/>
-                          </a:solidFill>
-                        </a:defRPr>
-                      </a:pPr>
-                      <a:r>
-                        <a:t>BFSI</a:t>
-                      </a:r>
-                    </a:p>
-                  </a:txBody>
-                  <a:tcPr/>
-                </a:tc>
-                <a:tc>
-                  <a:txBody>
-                    <a:bodyPr/>
-                    <a:lstStyle/>
-                    <a:p>
-                      <a:pPr>
-                        <a:defRPr sz="1000">
-                          <a:solidFill>
-                            <a:srgbClr val="333333"/>
-                          </a:solidFill>
-                        </a:defRPr>
-                      </a:pPr>
-                      <a:r>
-                        <a:t>Tier 3</a:t>
+                        <a:t>KENNAMETAL DISTRIBUTION SERVICES ASIA PTE. LT</a:t>
+                      </a:r>
+                    </a:p>
+                  </a:txBody>
+                  <a:tcPr/>
+                </a:tc>
+                <a:tc>
+                  <a:txBody>
+                    <a:bodyPr/>
+                    <a:lstStyle/>
+                    <a:p>
+                      <a:pPr>
+                        <a:defRPr sz="1000">
+                          <a:solidFill>
+                            <a:srgbClr val="333333"/>
+                          </a:solidFill>
+                        </a:defRPr>
+                      </a:pPr>
+                      <a:r>
+                        <a:t>Wholesale Distribution</a:t>
+                      </a:r>
+                    </a:p>
+                  </a:txBody>
+                  <a:tcPr/>
+                </a:tc>
+                <a:tc>
+                  <a:txBody>
+                    <a:bodyPr/>
+                    <a:lstStyle/>
+                    <a:p>
+                      <a:pPr>
+                        <a:defRPr sz="1000">
+                          <a:solidFill>
+                            <a:srgbClr val="333333"/>
+                          </a:solidFill>
+                        </a:defRPr>
+                      </a:pPr>
+                      <a:r>
+                        <a:t>Tier 1</a:t>
                       </a:r>
                     </a:p>
                   </a:txBody>
@@ -6971,26 +7014,26 @@
                         </a:defRPr>
                       </a:pPr>
                       <a:r>
-                        <a:t>$67.8B</a:t>
-                      </a:r>
-                    </a:p>
-                  </a:txBody>
-                  <a:tcPr/>
-                </a:tc>
-                <a:tc>
-                  <a:txBody>
-                    <a:bodyPr/>
-                    <a:lstStyle/>
-                    <a:p>
-                      <a:pPr>
-                        <a:defRPr sz="1000">
-                          <a:solidFill>
-                            <a:srgbClr val="333333"/>
-                          </a:solidFill>
-                        </a:defRPr>
-                      </a:pPr>
-                      <a:r>
-                        <a:t>6</a:t>
+                        <a:t>$43.0B</a:t>
+                      </a:r>
+                    </a:p>
+                  </a:txBody>
+                  <a:tcPr/>
+                </a:tc>
+                <a:tc>
+                  <a:txBody>
+                    <a:bodyPr/>
+                    <a:lstStyle/>
+                    <a:p>
+                      <a:pPr>
+                        <a:defRPr sz="1000">
+                          <a:solidFill>
+                            <a:srgbClr val="333333"/>
+                          </a:solidFill>
+                        </a:defRPr>
+                      </a:pPr>
+                      <a:r>
+                        <a:t>7</a:t>
                       </a:r>
                     </a:p>
                   </a:txBody>
@@ -7030,26 +7073,26 @@
                         </a:defRPr>
                       </a:pPr>
                       <a:r>
-                        <a:t>The Monetary Authority of Singapore</a:t>
-                      </a:r>
-                    </a:p>
-                  </a:txBody>
-                  <a:tcPr/>
-                </a:tc>
-                <a:tc>
-                  <a:txBody>
-                    <a:bodyPr/>
-                    <a:lstStyle/>
-                    <a:p>
-                      <a:pPr>
-                        <a:defRPr sz="1000">
-                          <a:solidFill>
-                            <a:srgbClr val="333333"/>
-                          </a:solidFill>
-                        </a:defRPr>
-                      </a:pPr>
-                      <a:r>
-                        <a:t>BFSI</a:t>
+                        <a:t>GLENCORE SINGAPORE PTE. LTD.</a:t>
+                      </a:r>
+                    </a:p>
+                  </a:txBody>
+                  <a:tcPr/>
+                </a:tc>
+                <a:tc>
+                  <a:txBody>
+                    <a:bodyPr/>
+                    <a:lstStyle/>
+                    <a:p>
+                      <a:pPr>
+                        <a:defRPr sz="1000">
+                          <a:solidFill>
+                            <a:srgbClr val="333333"/>
+                          </a:solidFill>
+                        </a:defRPr>
+                      </a:pPr>
+                      <a:r>
+                        <a:t>Energy &amp; Utility</a:t>
                       </a:r>
                     </a:p>
                   </a:txBody>
@@ -7106,26 +7149,26 @@
                         </a:defRPr>
                       </a:pPr>
                       <a:r>
-                        <a:t>$10.7B</a:t>
-                      </a:r>
-                    </a:p>
-                  </a:txBody>
-                  <a:tcPr/>
-                </a:tc>
-                <a:tc>
-                  <a:txBody>
-                    <a:bodyPr/>
-                    <a:lstStyle/>
-                    <a:p>
-                      <a:pPr>
-                        <a:defRPr sz="1000">
-                          <a:solidFill>
-                            <a:srgbClr val="333333"/>
-                          </a:solidFill>
-                        </a:defRPr>
-                      </a:pPr>
-                      <a:r>
-                        <a:t>6</a:t>
+                        <a:t>$39.1B</a:t>
+                      </a:r>
+                    </a:p>
+                  </a:txBody>
+                  <a:tcPr/>
+                </a:tc>
+                <a:tc>
+                  <a:txBody>
+                    <a:bodyPr/>
+                    <a:lstStyle/>
+                    <a:p>
+                      <a:pPr>
+                        <a:defRPr sz="1000">
+                          <a:solidFill>
+                            <a:srgbClr val="333333"/>
+                          </a:solidFill>
+                        </a:defRPr>
+                      </a:pPr>
+                      <a:r>
+                        <a:t>7</a:t>
                       </a:r>
                     </a:p>
                   </a:txBody>
@@ -7165,7 +7208,7 @@
                         </a:defRPr>
                       </a:pPr>
                       <a:r>
-                        <a:t>APPLE SOUTH ASIA PTE. LTD.</a:t>
+                        <a:t>APPLIED MATERIALS SOUTH EAST ASIA PTE. LTD.</a:t>
                       </a:r>
                     </a:p>
                   </a:txBody>
@@ -7203,7 +7246,7 @@
                         </a:defRPr>
                       </a:pPr>
                       <a:r>
-                        <a:t>Tier 3</a:t>
+                        <a:t>Tier 1</a:t>
                       </a:r>
                     </a:p>
                   </a:txBody>
@@ -7241,26 +7284,26 @@
                         </a:defRPr>
                       </a:pPr>
                       <a:r>
-                        <a:t>$111.5B</a:t>
-                      </a:r>
-                    </a:p>
-                  </a:txBody>
-                  <a:tcPr/>
-                </a:tc>
-                <a:tc>
-                  <a:txBody>
-                    <a:bodyPr/>
-                    <a:lstStyle/>
-                    <a:p>
-                      <a:pPr>
-                        <a:defRPr sz="1000">
-                          <a:solidFill>
-                            <a:srgbClr val="333333"/>
-                          </a:solidFill>
-                        </a:defRPr>
-                      </a:pPr>
-                      <a:r>
-                        <a:t>6</a:t>
+                        <a:t>$21.7B</a:t>
+                      </a:r>
+                    </a:p>
+                  </a:txBody>
+                  <a:tcPr/>
+                </a:tc>
+                <a:tc>
+                  <a:txBody>
+                    <a:bodyPr/>
+                    <a:lstStyle/>
+                    <a:p>
+                      <a:pPr>
+                        <a:defRPr sz="1000">
+                          <a:solidFill>
+                            <a:srgbClr val="333333"/>
+                          </a:solidFill>
+                        </a:defRPr>
+                      </a:pPr>
+                      <a:r>
+                        <a:t>7</a:t>
                       </a:r>
                     </a:p>
                   </a:txBody>
@@ -7300,45 +7343,45 @@
                         </a:defRPr>
                       </a:pPr>
                       <a:r>
-                        <a:t>Temasek</a:t>
-                      </a:r>
-                    </a:p>
-                  </a:txBody>
-                  <a:tcPr/>
-                </a:tc>
-                <a:tc>
-                  <a:txBody>
-                    <a:bodyPr/>
-                    <a:lstStyle/>
-                    <a:p>
-                      <a:pPr>
-                        <a:defRPr sz="1000">
-                          <a:solidFill>
-                            <a:srgbClr val="333333"/>
-                          </a:solidFill>
-                        </a:defRPr>
-                      </a:pPr>
-                      <a:r>
-                        <a:t>BFSI</a:t>
-                      </a:r>
-                    </a:p>
-                  </a:txBody>
-                  <a:tcPr/>
-                </a:tc>
-                <a:tc>
-                  <a:txBody>
-                    <a:bodyPr/>
-                    <a:lstStyle/>
-                    <a:p>
-                      <a:pPr>
-                        <a:defRPr sz="1000">
-                          <a:solidFill>
-                            <a:srgbClr val="333333"/>
-                          </a:solidFill>
-                        </a:defRPr>
-                      </a:pPr>
-                      <a:r>
-                        <a:t>Tier 3</a:t>
+                        <a:t>MITSUBISHI CORPORATION RTM INTERNATIONAL PTE.</a:t>
+                      </a:r>
+                    </a:p>
+                  </a:txBody>
+                  <a:tcPr/>
+                </a:tc>
+                <a:tc>
+                  <a:txBody>
+                    <a:bodyPr/>
+                    <a:lstStyle/>
+                    <a:p>
+                      <a:pPr>
+                        <a:defRPr sz="1000">
+                          <a:solidFill>
+                            <a:srgbClr val="333333"/>
+                          </a:solidFill>
+                        </a:defRPr>
+                      </a:pPr>
+                      <a:r>
+                        <a:t>Wholesale Distribution</a:t>
+                      </a:r>
+                    </a:p>
+                  </a:txBody>
+                  <a:tcPr/>
+                </a:tc>
+                <a:tc>
+                  <a:txBody>
+                    <a:bodyPr/>
+                    <a:lstStyle/>
+                    <a:p>
+                      <a:pPr>
+                        <a:defRPr sz="1000">
+                          <a:solidFill>
+                            <a:srgbClr val="333333"/>
+                          </a:solidFill>
+                        </a:defRPr>
+                      </a:pPr>
+                      <a:r>
+                        <a:t>Tier 1</a:t>
                       </a:r>
                     </a:p>
                   </a:txBody>
@@ -7376,26 +7419,26 @@
                         </a:defRPr>
                       </a:pPr>
                       <a:r>
-                        <a:t>$125.9B</a:t>
-                      </a:r>
-                    </a:p>
-                  </a:txBody>
-                  <a:tcPr/>
-                </a:tc>
-                <a:tc>
-                  <a:txBody>
-                    <a:bodyPr/>
-                    <a:lstStyle/>
-                    <a:p>
-                      <a:pPr>
-                        <a:defRPr sz="1000">
-                          <a:solidFill>
-                            <a:srgbClr val="333333"/>
-                          </a:solidFill>
-                        </a:defRPr>
-                      </a:pPr>
-                      <a:r>
-                        <a:t>6</a:t>
+                        <a:t>$6.0B</a:t>
+                      </a:r>
+                    </a:p>
+                  </a:txBody>
+                  <a:tcPr/>
+                </a:tc>
+                <a:tc>
+                  <a:txBody>
+                    <a:bodyPr/>
+                    <a:lstStyle/>
+                    <a:p>
+                      <a:pPr>
+                        <a:defRPr sz="1000">
+                          <a:solidFill>
+                            <a:srgbClr val="333333"/>
+                          </a:solidFill>
+                        </a:defRPr>
+                      </a:pPr>
+                      <a:r>
+                        <a:t>7</a:t>
                       </a:r>
                     </a:p>
                   </a:txBody>
@@ -7435,7 +7478,7 @@
                         </a:defRPr>
                       </a:pPr>
                       <a:r>
-                        <a:t>TOTALENERGIES TRADING ASIA PTE. LTD.</a:t>
+                        <a:t>PHILLIPS 66 INTERNATIONAL TRADING PTE. LTD.</a:t>
                       </a:r>
                     </a:p>
                   </a:txBody>
@@ -7473,7 +7516,7 @@
                         </a:defRPr>
                       </a:pPr>
                       <a:r>
-                        <a:t>Tier 3</a:t>
+                        <a:t>Tier 1</a:t>
                       </a:r>
                     </a:p>
                   </a:txBody>
@@ -7511,26 +7554,26 @@
                         </a:defRPr>
                       </a:pPr>
                       <a:r>
-                        <a:t>$50.3B</a:t>
-                      </a:r>
-                    </a:p>
-                  </a:txBody>
-                  <a:tcPr/>
-                </a:tc>
-                <a:tc>
-                  <a:txBody>
-                    <a:bodyPr/>
-                    <a:lstStyle/>
-                    <a:p>
-                      <a:pPr>
-                        <a:defRPr sz="1000">
-                          <a:solidFill>
-                            <a:srgbClr val="333333"/>
-                          </a:solidFill>
-                        </a:defRPr>
-                      </a:pPr>
-                      <a:r>
-                        <a:t>6</a:t>
+                        <a:t>$11.8B</a:t>
+                      </a:r>
+                    </a:p>
+                  </a:txBody>
+                  <a:tcPr/>
+                </a:tc>
+                <a:tc>
+                  <a:txBody>
+                    <a:bodyPr/>
+                    <a:lstStyle/>
+                    <a:p>
+                      <a:pPr>
+                        <a:defRPr sz="1000">
+                          <a:solidFill>
+                            <a:srgbClr val="333333"/>
+                          </a:solidFill>
+                        </a:defRPr>
+                      </a:pPr>
+                      <a:r>
+                        <a:t>7</a:t>
                       </a:r>
                     </a:p>
                   </a:txBody>
@@ -7570,26 +7613,26 @@
                         </a:defRPr>
                       </a:pPr>
                       <a:r>
-                        <a:t>ASE Singapore Pte Ltd</a:t>
-                      </a:r>
-                    </a:p>
-                  </a:txBody>
-                  <a:tcPr/>
-                </a:tc>
-                <a:tc>
-                  <a:txBody>
-                    <a:bodyPr/>
-                    <a:lstStyle/>
-                    <a:p>
-                      <a:pPr>
-                        <a:defRPr sz="1000">
-                          <a:solidFill>
-                            <a:srgbClr val="333333"/>
-                          </a:solidFill>
-                        </a:defRPr>
-                      </a:pPr>
-                      <a:r>
-                        <a:t>Electronics</a:t>
+                        <a:t>CARGILL INTERNATIONAL TRADING PTE LTD</a:t>
+                      </a:r>
+                    </a:p>
+                  </a:txBody>
+                  <a:tcPr/>
+                </a:tc>
+                <a:tc>
+                  <a:txBody>
+                    <a:bodyPr/>
+                    <a:lstStyle/>
+                    <a:p>
+                      <a:pPr>
+                        <a:defRPr sz="1000">
+                          <a:solidFill>
+                            <a:srgbClr val="333333"/>
+                          </a:solidFill>
+                        </a:defRPr>
+                      </a:pPr>
+                      <a:r>
+                        <a:t>BFSI</a:t>
                       </a:r>
                     </a:p>
                   </a:txBody>
@@ -7646,26 +7689,26 @@
                         </a:defRPr>
                       </a:pPr>
                       <a:r>
-                        <a:t>$18.4B</a:t>
-                      </a:r>
-                    </a:p>
-                  </a:txBody>
-                  <a:tcPr/>
-                </a:tc>
-                <a:tc>
-                  <a:txBody>
-                    <a:bodyPr/>
-                    <a:lstStyle/>
-                    <a:p>
-                      <a:pPr>
-                        <a:defRPr sz="1000">
-                          <a:solidFill>
-                            <a:srgbClr val="333333"/>
-                          </a:solidFill>
-                        </a:defRPr>
-                      </a:pPr>
-                      <a:r>
-                        <a:t>6</a:t>
+                        <a:t>$11.6B</a:t>
+                      </a:r>
+                    </a:p>
+                  </a:txBody>
+                  <a:tcPr/>
+                </a:tc>
+                <a:tc>
+                  <a:txBody>
+                    <a:bodyPr/>
+                    <a:lstStyle/>
+                    <a:p>
+                      <a:pPr>
+                        <a:defRPr sz="1000">
+                          <a:solidFill>
+                            <a:srgbClr val="333333"/>
+                          </a:solidFill>
+                        </a:defRPr>
+                      </a:pPr>
+                      <a:r>
+                        <a:t>7</a:t>
                       </a:r>
                     </a:p>
                   </a:txBody>
@@ -7706,7 +7749,7 @@
               </a:defRPr>
             </a:pPr>
             <a:r>
-              <a:t>Scoring: Tier1=3pts, Tier2=2pts, Tier3=1pt | Migration=2pts, ManagedSvc=1pt | SAP Base=1pt | Rev&gt;$50B=2pts, &gt;$20B=1pt</a:t>
+              <a:t>Scoring: Tier1=3 | Tier2=2 | Tier3=1 | Migration=2 | ManagedSvc=1 | SAP Base=1 | LE Qualified(&gt;$5B)=1 | Max=8 | Source: Ops</a:t>
             </a:r>
           </a:p>
         </p:txBody>
@@ -7759,7 +7802,7 @@
               </a:defRPr>
             </a:pPr>
             <a:r>
-              <a:t>SOURCE GAP ANALYSIS — NTT vs SAP MOVE</a:t>
+              <a:t>AUDIT TRAIL — OPS vs SAP SOURCE GAP</a:t>
             </a:r>
           </a:p>
         </p:txBody>
@@ -7794,7 +7837,7 @@
               </a:defRPr>
             </a:pPr>
             <a:r>
-              <a:t>NTT ONLY (109 accounts)</a:t>
+              <a:t>OPS ONLY (109 accounts)</a:t>
             </a:r>
           </a:p>
         </p:txBody>
@@ -7829,7 +7872,7 @@
               </a:defRPr>
             </a:pPr>
             <a:r>
-              <a:t>Source: Aashita/Ops</a:t>
+              <a:t>Source: Aashita/NTT Operations</a:t>
             </a:r>
           </a:p>
         </p:txBody>
@@ -7860,14 +7903,14 @@
               <a:spcAft>
                 <a:spcPts val="400"/>
               </a:spcAft>
-              <a:defRPr sz="1100">
+              <a:defRPr sz="1200">
                 <a:solidFill>
                   <a:srgbClr val="333333"/>
                 </a:solidFill>
               </a:defRPr>
             </a:pPr>
             <a:r>
-              <a:t>• Accounts on NTT target list</a:t>
+              <a:t>• On Ops target list (SG Sheet)</a:t>
             </a:r>
           </a:p>
           <a:p>
@@ -7875,7 +7918,7 @@
               <a:spcAft>
                 <a:spcPts val="400"/>
               </a:spcAft>
-              <a:defRPr sz="1100">
+              <a:defRPr sz="1200">
                 <a:solidFill>
                   <a:srgbClr val="333333"/>
                 </a:solidFill>
@@ -7890,14 +7933,14 @@
               <a:spcAft>
                 <a:spcPts val="400"/>
               </a:spcAft>
-              <a:defRPr sz="1100">
+              <a:defRPr sz="1200">
                 <a:solidFill>
                   <a:srgbClr val="333333"/>
                 </a:solidFill>
               </a:defRPr>
             </a:pPr>
             <a:r>
-              <a:t>• May need SAP alignment check</a:t>
+              <a:t>• May need SAP team validation</a:t>
             </a:r>
           </a:p>
           <a:p>
@@ -7905,14 +7948,14 @@
               <a:spcAft>
                 <a:spcPts val="400"/>
               </a:spcAft>
-              <a:defRPr sz="1100">
+              <a:defRPr sz="1200">
                 <a:solidFill>
                   <a:srgbClr val="333333"/>
                 </a:solidFill>
               </a:defRPr>
             </a:pPr>
             <a:r>
-              <a:t>• Key names: Wilmar, Standard Chartered,</a:t>
+              <a:t>• Key: Wilmar, Standard Chartered,</a:t>
             </a:r>
           </a:p>
           <a:p>
@@ -7920,7 +7963,7 @@
               <a:spcAft>
                 <a:spcPts val="400"/>
               </a:spcAft>
-              <a:defRPr sz="1100">
+              <a:defRPr sz="1200">
                 <a:solidFill>
                   <a:srgbClr val="333333"/>
                 </a:solidFill>
@@ -7935,7 +7978,7 @@
               <a:spcAft>
                 <a:spcPts val="400"/>
               </a:spcAft>
-              <a:defRPr sz="1100">
+              <a:defRPr sz="1200">
                 <a:solidFill>
                   <a:srgbClr val="333333"/>
                 </a:solidFill>
@@ -8012,7 +8055,7 @@
               </a:defRPr>
             </a:pPr>
             <a:r>
-              <a:t>Aligned targets</a:t>
+              <a:t>Confirmed by Ops AND SAP</a:t>
             </a:r>
           </a:p>
         </p:txBody>
@@ -8043,7 +8086,7 @@
               <a:spcAft>
                 <a:spcPts val="400"/>
               </a:spcAft>
-              <a:defRPr sz="1100">
+              <a:defRPr sz="1200">
                 <a:solidFill>
                   <a:srgbClr val="333333"/>
                 </a:solidFill>
@@ -8058,7 +8101,7 @@
               <a:spcAft>
                 <a:spcPts val="400"/>
               </a:spcAft>
-              <a:defRPr sz="1100">
+              <a:defRPr sz="1200">
                 <a:solidFill>
                   <a:srgbClr val="333333"/>
                 </a:solidFill>
@@ -8073,7 +8116,7 @@
               <a:spcAft>
                 <a:spcPts val="400"/>
               </a:spcAft>
-              <a:defRPr sz="1100">
+              <a:defRPr sz="1200">
                 <a:solidFill>
                   <a:srgbClr val="333333"/>
                 </a:solidFill>
@@ -8088,7 +8131,7 @@
               <a:spcAft>
                 <a:spcPts val="400"/>
               </a:spcAft>
-              <a:defRPr sz="1100">
+              <a:defRPr sz="1200">
                 <a:solidFill>
                   <a:srgbClr val="333333"/>
                 </a:solidFill>
@@ -8103,7 +8146,7 @@
               <a:spcAft>
                 <a:spcPts val="400"/>
               </a:spcAft>
-              <a:defRPr sz="1100">
+              <a:defRPr sz="1200">
                 <a:solidFill>
                   <a:srgbClr val="333333"/>
                 </a:solidFill>
@@ -8118,7 +8161,7 @@
               <a:spcAft>
                 <a:spcPts val="400"/>
               </a:spcAft>
-              <a:defRPr sz="1100">
+              <a:defRPr sz="1200">
                 <a:solidFill>
                   <a:srgbClr val="333333"/>
                 </a:solidFill>
@@ -8133,29 +8176,14 @@
               <a:spcAft>
                 <a:spcPts val="400"/>
               </a:spcAft>
-              <a:defRPr sz="1100">
+              <a:defRPr sz="1200">
                 <a:solidFill>
                   <a:srgbClr val="333333"/>
                 </a:solidFill>
               </a:defRPr>
             </a:pPr>
             <a:r>
-              <a:t>• Action: Prioritize — highest</a:t>
-            </a:r>
-          </a:p>
-          <a:p>
-            <a:pPr>
-              <a:spcAft>
-                <a:spcPts val="400"/>
-              </a:spcAft>
-              <a:defRPr sz="1100">
-                <a:solidFill>
-                  <a:srgbClr val="333333"/>
-                </a:solidFill>
-              </a:defRPr>
-            </a:pPr>
-            <a:r>
-              <a:t>•   confidence targets</a:t>
+              <a:t>• Action: Highest-confidence targets</a:t>
             </a:r>
           </a:p>
         </p:txBody>
@@ -8190,7 +8218,7 @@
               </a:defRPr>
             </a:pPr>
             <a:r>
-              <a:t>SAP MOVE ONLY (69)</a:t>
+              <a:t>SAP ONLY (69 accounts)</a:t>
             </a:r>
           </a:p>
         </p:txBody>
@@ -8256,7 +8284,7 @@
               <a:spcAft>
                 <a:spcPts val="400"/>
               </a:spcAft>
-              <a:defRPr sz="1100">
+              <a:defRPr sz="1200">
                 <a:solidFill>
                   <a:srgbClr val="333333"/>
                 </a:solidFill>
@@ -8271,14 +8299,14 @@
               <a:spcAft>
                 <a:spcPts val="400"/>
               </a:spcAft>
-              <a:defRPr sz="1100">
+              <a:defRPr sz="1200">
                 <a:solidFill>
                   <a:srgbClr val="333333"/>
                 </a:solidFill>
               </a:defRPr>
             </a:pPr>
             <a:r>
-              <a:t>• NOT on NTT target list</a:t>
+              <a:t>• NOT on Ops target list</a:t>
             </a:r>
           </a:p>
           <a:p>
@@ -8286,7 +8314,7 @@
               <a:spcAft>
                 <a:spcPts val="400"/>
               </a:spcAft>
-              <a:defRPr sz="1100">
+              <a:defRPr sz="1200">
                 <a:solidFill>
                   <a:srgbClr val="333333"/>
                 </a:solidFill>
@@ -8301,7 +8329,7 @@
               <a:spcAft>
                 <a:spcPts val="400"/>
               </a:spcAft>
-              <a:defRPr sz="1100">
+              <a:defRPr sz="1200">
                 <a:solidFill>
                   <a:srgbClr val="333333"/>
                 </a:solidFill>
@@ -8316,7 +8344,7 @@
               <a:spcAft>
                 <a:spcPts val="400"/>
               </a:spcAft>
-              <a:defRPr sz="1100">
+              <a:defRPr sz="1200">
                 <a:solidFill>
                   <a:srgbClr val="333333"/>
                 </a:solidFill>
@@ -8331,14 +8359,14 @@
               <a:spcAft>
                 <a:spcPts val="400"/>
               </a:spcAft>
-              <a:defRPr sz="1100">
+              <a:defRPr sz="1200">
                 <a:solidFill>
                   <a:srgbClr val="333333"/>
                 </a:solidFill>
               </a:defRPr>
             </a:pPr>
             <a:r>
-              <a:t>• Action: Review for NTT list inclusion</a:t>
+              <a:t>• Action: Review for Ops list inclusion</a:t>
             </a:r>
           </a:p>
         </p:txBody>
@@ -8373,7 +8401,7 @@
               </a:defRPr>
             </a:pPr>
             <a:r>
-              <a:t>CRITICAL: Low overlap (3.3%) between NTT and SAP lists suggests significant misalignment or complementary targeting strategies that need reconciliation.</a:t>
+              <a:t>CRITICAL: Only 3.3% overlap — significant gap between Ops and SAP targeting. Reconciliation needed.</a:t>
             </a:r>
           </a:p>
         </p:txBody>
@@ -8439,8 +8467,8 @@
         </p:nvSpPr>
         <p:spPr>
           <a:xfrm>
-            <a:off x="457200" y="1097280"/>
-            <a:ext cx="5029200" cy="457200"/>
+            <a:off x="457200" y="914400"/>
+            <a:ext cx="10972800" cy="365760"/>
           </a:xfrm>
           <a:prstGeom prst="rect">
             <a:avLst/>
@@ -8454,6 +8482,41 @@
           <a:lstStyle/>
           <a:p>
             <a:pPr algn="l">
+              <a:defRPr sz="1200" b="1">
+                <a:solidFill>
+                  <a:srgbClr val="BF8F00"/>
+                </a:solidFill>
+              </a:defRPr>
+            </a:pPr>
+            <a:r>
+              <a:t>Source: SAP SEA MOVE LIST -LE (SAP data)</a:t>
+            </a:r>
+          </a:p>
+        </p:txBody>
+      </p:sp>
+      <p:sp>
+        <p:nvSpPr>
+          <p:cNvPr id="4" name="TextBox 3"/>
+          <p:cNvSpPr txBox="1"/>
+          <p:nvPr/>
+        </p:nvSpPr>
+        <p:spPr>
+          <a:xfrm>
+            <a:off x="457200" y="1371600"/>
+            <a:ext cx="4572000" cy="365760"/>
+          </a:xfrm>
+          <a:prstGeom prst="rect">
+            <a:avLst/>
+          </a:prstGeom>
+          <a:noFill/>
+        </p:spPr>
+        <p:txBody>
+          <a:bodyPr wrap="square">
+            <a:spAutoFit/>
+          </a:bodyPr>
+          <a:lstStyle/>
+          <a:p>
+            <a:pPr algn="l">
               <a:defRPr sz="1600" b="1">
                 <a:solidFill>
                   <a:srgbClr val="1F4E79"/>
@@ -8468,14 +8531,14 @@
       </p:sp>
       <p:graphicFrame>
         <p:nvGraphicFramePr>
-          <p:cNvPr id="4" name="Table 3"/>
+          <p:cNvPr id="5" name="Table 4"/>
           <p:cNvGraphicFramePr>
             <a:graphicFrameLocks noGrp="1"/>
           </p:cNvGraphicFramePr>
           <p:nvPr/>
         </p:nvGraphicFramePr>
         <p:xfrm>
-          <a:off x="457200" y="1645920"/>
+          <a:off x="457200" y="1828800"/>
           <a:ext cx="3657600" cy="1097280"/>
         </p:xfrm>
         <a:graphic>
@@ -8684,14 +8747,14 @@
       </p:graphicFrame>
       <p:sp>
         <p:nvSpPr>
-          <p:cNvPr id="5" name="TextBox 4"/>
+          <p:cNvPr id="6" name="TextBox 5"/>
           <p:cNvSpPr txBox="1"/>
           <p:nvPr/>
         </p:nvSpPr>
         <p:spPr>
           <a:xfrm>
-            <a:off x="457200" y="3017520"/>
-            <a:ext cx="5029200" cy="457200"/>
+            <a:off x="457200" y="3200400"/>
+            <a:ext cx="4572000" cy="365760"/>
           </a:xfrm>
           <a:prstGeom prst="rect">
             <a:avLst/>
@@ -8719,14 +8782,14 @@
       </p:sp>
       <p:graphicFrame>
         <p:nvGraphicFramePr>
-          <p:cNvPr id="6" name="Table 5"/>
+          <p:cNvPr id="7" name="Table 6"/>
           <p:cNvGraphicFramePr>
             <a:graphicFrameLocks noGrp="1"/>
           </p:cNvGraphicFramePr>
           <p:nvPr/>
         </p:nvGraphicFramePr>
         <p:xfrm>
-          <a:off x="457200" y="3566160"/>
+          <a:off x="457200" y="3657600"/>
           <a:ext cx="3657600" cy="1371600"/>
         </p:xfrm>
         <a:graphic>
@@ -8994,14 +9057,14 @@
       </p:graphicFrame>
       <p:sp>
         <p:nvSpPr>
-          <p:cNvPr id="7" name="TextBox 6"/>
+          <p:cNvPr id="8" name="TextBox 7"/>
           <p:cNvSpPr txBox="1"/>
           <p:nvPr/>
         </p:nvSpPr>
         <p:spPr>
           <a:xfrm>
-            <a:off x="5486400" y="1097280"/>
-            <a:ext cx="5486400" cy="457200"/>
+            <a:off x="5486400" y="1371600"/>
+            <a:ext cx="5486400" cy="365760"/>
           </a:xfrm>
           <a:prstGeom prst="rect">
             <a:avLst/>
@@ -9029,14 +9092,14 @@
       </p:sp>
       <p:graphicFrame>
         <p:nvGraphicFramePr>
-          <p:cNvPr id="8" name="Table 7"/>
+          <p:cNvPr id="9" name="Table 8"/>
           <p:cNvGraphicFramePr>
             <a:graphicFrameLocks noGrp="1"/>
           </p:cNvGraphicFramePr>
           <p:nvPr/>
         </p:nvGraphicFramePr>
         <p:xfrm>
-          <a:off x="5486400" y="1645920"/>
+          <a:off x="5486400" y="1828800"/>
           <a:ext cx="5486400" cy="3200400"/>
         </p:xfrm>
         <a:graphic>
@@ -9421,76 +9484,6 @@
           </a:graphicData>
         </a:graphic>
       </p:graphicFrame>
-      <p:sp>
-        <p:nvSpPr>
-          <p:cNvPr id="9" name="TextBox 8"/>
-          <p:cNvSpPr txBox="1"/>
-          <p:nvPr/>
-        </p:nvSpPr>
-        <p:spPr>
-          <a:xfrm>
-            <a:off x="457200" y="5303520"/>
-            <a:ext cx="10972800" cy="457200"/>
-          </a:xfrm>
-          <a:prstGeom prst="rect">
-            <a:avLst/>
-          </a:prstGeom>
-          <a:noFill/>
-        </p:spPr>
-        <p:txBody>
-          <a:bodyPr wrap="square">
-            <a:spAutoFit/>
-          </a:bodyPr>
-          <a:lstStyle/>
-          <a:p>
-            <a:pPr algn="l">
-              <a:defRPr sz="1100" b="1">
-                <a:solidFill>
-                  <a:srgbClr val="BF8F00"/>
-                </a:solidFill>
-              </a:defRPr>
-            </a:pPr>
-            <a:r>
-              <a:t>NOTE: SAP defines LE differently from NTT. All 75 SG accounts have MA &gt;= $100K.</a:t>
-            </a:r>
-          </a:p>
-        </p:txBody>
-      </p:sp>
-      <p:sp>
-        <p:nvSpPr>
-          <p:cNvPr id="10" name="TextBox 9"/>
-          <p:cNvSpPr txBox="1"/>
-          <p:nvPr/>
-        </p:nvSpPr>
-        <p:spPr>
-          <a:xfrm>
-            <a:off x="457200" y="5760720"/>
-            <a:ext cx="10972800" cy="457200"/>
-          </a:xfrm>
-          <a:prstGeom prst="rect">
-            <a:avLst/>
-          </a:prstGeom>
-          <a:noFill/>
-        </p:spPr>
-        <p:txBody>
-          <a:bodyPr wrap="square">
-            <a:spAutoFit/>
-          </a:bodyPr>
-          <a:lstStyle/>
-          <a:p>
-            <a:pPr algn="l">
-              <a:defRPr sz="1000" b="0">
-                <a:solidFill>
-                  <a:srgbClr val="808080"/>
-                </a:solidFill>
-              </a:defRPr>
-            </a:pPr>
-            <a:r>
-              <a:t>Source: SAP SEA MOVE LIST -LE sheet</a:t>
-            </a:r>
-          </a:p>
-        </p:txBody>
-      </p:sp>
     </p:spTree>
   </p:cSld>
   <p:clrMapOvr>
@@ -9672,7 +9665,7 @@
               </a:defRPr>
             </a:pPr>
             <a:r>
-              <a:t>• None flagged as compete situations</a:t>
+              <a:t>• Source: AMS (Not Active SAP Cust) sheet</a:t>
             </a:r>
           </a:p>
         </p:txBody>
@@ -9707,7 +9700,7 @@
               </a:defRPr>
             </a:pPr>
             <a:r>
-              <a:t>NOT-ACTIVE AMS ACCOUNTS — REACTIVATION TARGETS</a:t>
+              <a:t>NOT-ACTIVE AMS — REACTIVATION TARGETS</a:t>
             </a:r>
           </a:p>
         </p:txBody>
@@ -10529,7 +10522,7 @@
               </a:defRPr>
             </a:pPr>
             <a:r>
-              <a:t>• Reconcile NTT target list with SAP MOVE list — 6 overlapping accounts are priority #1</a:t>
+              <a:t>• Reconcile Ops target list with SAP MOVE list — 6 overlapping accounts are priority #1</a:t>
             </a:r>
           </a:p>
           <a:p>
@@ -10544,7 +10537,7 @@
               </a:defRPr>
             </a:pPr>
             <a:r>
-              <a:t>• Review 69 SAP MOVE-only accounts for inclusion in NTT pipeline</a:t>
+              <a:t>• Review 69 SAP-only accounts for inclusion in Ops pipeline</a:t>
             </a:r>
           </a:p>
           <a:p>
@@ -10559,7 +10552,7 @@
               </a:defRPr>
             </a:pPr>
             <a:r>
-              <a:t>• Validate 109 NTT-only accounts with SAP team for MOVE eligibility</a:t>
+              <a:t>• Validate 109 Ops-only accounts with SAP team for MOVE eligibility</a:t>
             </a:r>
           </a:p>
           <a:p>
@@ -10810,7 +10803,7 @@
               </a:defRPr>
             </a:pPr>
             <a:r>
-              <a:t>• Quarterly NTT-SAP alignment review to reduce list gap</a:t>
+              <a:t>• Quarterly Ops-SAP alignment review to reduce list gap</a:t>
             </a:r>
           </a:p>
         </p:txBody>
@@ -10863,7 +10856,7 @@
               </a:defRPr>
             </a:pPr>
             <a:r>
-              <a:t>NTT URGENCY TIER BREAKDOWN</a:t>
+              <a:t>NTT URGENCY TIER BREAKDOWN (Source: Ops)</a:t>
             </a:r>
           </a:p>
         </p:txBody>

</xml_diff>